<commit_message>
Course 4: patch sections 1-10 for the code fixes; regenerate decks
- 419 tests; retry1 and slow-provider figures; keyed HMAC hash demo with
  new values; collector deletes user ids; judge output and sampling rules;
  PII demo rewritten for the zero-flag replayed day; deterministic
  candidate check; release-annotation query; dotenv and /metrics notes

Co-Authored-By: Claude Fable 5.1 <noreply@anthropic.com>
Claude-Session: https://claude.ai/code/session_01A5i6AjSXfF2UjeUjpNVFfS
</commit_message>
<xml_diff>
--- a/agent-observability-course/10-graphics/slides/section-04.pptx
+++ b/agent-observability-course/10-graphics/slides/section-04.pptx
@@ -10263,6 +10263,33 @@
                 <a:latin typeface="JetBrains Mono"/>
               </a:rPr>
               <a:t>scenario:*</a:t>
+            </a:r>
+            <a:r>
+              <a:rPr sz="1800" b="0">
+                <a:solidFill>
+                  <a:srgbClr val="FFFFFF"/>
+                </a:solidFill>
+                <a:latin typeface="Inter"/>
+              </a:rPr>
+              <a:t> (a replayed day also carries the plain tag </a:t>
+            </a:r>
+            <a:r>
+              <a:rPr sz="1656" b="0">
+                <a:solidFill>
+                  <a:srgbClr val="00D4AA"/>
+                </a:solidFill>
+                <a:latin typeface="JetBrains Mono"/>
+              </a:rPr>
+              <a:t>replay</a:t>
+            </a:r>
+            <a:r>
+              <a:rPr sz="1800" b="0">
+                <a:solidFill>
+                  <a:srgbClr val="FFFFFF"/>
+                </a:solidFill>
+                <a:latin typeface="Inter"/>
+              </a:rPr>
+              <a:t>, under the store's own trace ids)</a:t>
             </a:r>
           </a:p>
         </p:txBody>

</xml_diff>